<commit_message>
Update PowerPoint with enhanced team information from CV
</commit_message>
<xml_diff>
--- a/JAN20_pitch_deck.pptx
+++ b/JAN20_pitch_deck.pptx
@@ -5778,8 +5778,8 @@
         </p:nvSpPr>
         <p:spPr>
           <a:xfrm>
-            <a:off x="731520" y="1371600"/>
-            <a:ext cx="7680960" cy="4572000"/>
+            <a:off x="457200" y="1371600"/>
+            <a:ext cx="8229600" cy="5029200"/>
           </a:xfrm>
           <a:prstGeom prst="rect">
             <a:avLst/>
@@ -5794,31 +5794,226 @@
           <a:p>
             <a:pPr>
               <a:spcAft>
-                <a:spcPts val="1200"/>
-              </a:spcAft>
-              <a:defRPr sz="1400">
-                <a:solidFill>
-                  <a:srgbClr val="9CA3AF"/>
-                </a:solidFill>
-              </a:defRPr>
-            </a:pPr>
-            <a:r>
-              <a:t>CAYDEN AUYANG — Architect &amp; Founder. Expert in Agentic AI Workflows (Cursor + Google Antigravity) — capable of executing engineering tasks at 5x the speed of traditional developers, keeping burn rate near zero. Dedicated Gap Year (2026-2027): 100% full-time commitment to scaling the venture post-graduation. Developed the core 12-dimension taxonomy at the Civic AI Group, validating the framework with academic rigor.</a:t>
-            </a:r>
-          </a:p>
-          <a:p>
-            <a:pPr>
-              <a:spcAft>
-                <a:spcPts val="1200"/>
-              </a:spcAft>
-              <a:defRPr sz="1400">
-                <a:solidFill>
-                  <a:srgbClr val="9CA3AF"/>
-                </a:solidFill>
-              </a:defRPr>
-            </a:pPr>
-            <a:r>
-              <a:t>ALVIN MOK — Key Advisor. Chief Information and Data Officer at Select Equity Group (2025-Present). Previously: Head of Global Platform &amp; Insights at Orbis Investments ($25B+ AUM), led proprietary insights group conducting primary research and alternative data analysis (web data mining, transactional email databases) to inform investment decisions. McKinsey &amp; Company Engagement Manager (Asia, High Tech, Travel, Infrastructure). Harvard MBA (Baker Scholar — Top 5% of graduating class). University of Toronto Computer Engineering (Highest cumulative average in all of UofT, 2003).</a:t>
+                <a:spcPts val="600"/>
+              </a:spcAft>
+              <a:defRPr sz="1600" b="1">
+                <a:solidFill>
+                  <a:srgbClr val="4ADE80"/>
+                </a:solidFill>
+              </a:defRPr>
+            </a:pPr>
+            <a:r>
+              <a:t>CAYDEN AUYANG — Architect &amp; Founder</a:t>
+            </a:r>
+          </a:p>
+          <a:p>
+            <a:pPr>
+              <a:spcAft>
+                <a:spcPts val="600"/>
+              </a:spcAft>
+              <a:defRPr sz="1000">
+                <a:solidFill>
+                  <a:srgbClr val="9CA3AF"/>
+                </a:solidFill>
+              </a:defRPr>
+            </a:pPr>
+          </a:p>
+          <a:p>
+            <a:pPr>
+              <a:spcAft>
+                <a:spcPts val="600"/>
+              </a:spcAft>
+              <a:defRPr sz="1000">
+                <a:solidFill>
+                  <a:srgbClr val="9CA3AF"/>
+                </a:solidFill>
+              </a:defRPr>
+            </a:pPr>
+            <a:r>
+              <a:t>Education: Pomfret School (Head of School Scholar - Highest Academic Award)</a:t>
+            </a:r>
+          </a:p>
+          <a:p>
+            <a:pPr>
+              <a:spcAft>
+                <a:spcPts val="600"/>
+              </a:spcAft>
+              <a:defRPr sz="1000">
+                <a:solidFill>
+                  <a:srgbClr val="9CA3AF"/>
+                </a:solidFill>
+              </a:defRPr>
+            </a:pPr>
+            <a:r>
+              <a:t>Based: Hong Kong / Connecticut, USA | Languages: English/Cantonese (Native), Mandarin (Fluent), Spanish (Conversational)</a:t>
+            </a:r>
+          </a:p>
+          <a:p>
+            <a:pPr>
+              <a:spcAft>
+                <a:spcPts val="600"/>
+              </a:spcAft>
+              <a:defRPr sz="1000">
+                <a:solidFill>
+                  <a:srgbClr val="9CA3AF"/>
+                </a:solidFill>
+              </a:defRPr>
+            </a:pPr>
+            <a:r>
+              <a:t>Contact: caydenauyang@gmail.com | +852 9260 9370 | github.com/CaydenAuyang</a:t>
+            </a:r>
+          </a:p>
+          <a:p>
+            <a:pPr>
+              <a:spcAft>
+                <a:spcPts val="600"/>
+              </a:spcAft>
+              <a:defRPr sz="1000">
+                <a:solidFill>
+                  <a:srgbClr val="9CA3AF"/>
+                </a:solidFill>
+              </a:defRPr>
+            </a:pPr>
+          </a:p>
+          <a:p>
+            <a:pPr>
+              <a:spcAft>
+                <a:spcPts val="600"/>
+              </a:spcAft>
+              <a:defRPr sz="1100" b="1">
+                <a:solidFill>
+                  <a:srgbClr val="FFFFFF"/>
+                </a:solidFill>
+              </a:defRPr>
+            </a:pPr>
+            <a:r>
+              <a:t>Professional Experience:</a:t>
+            </a:r>
+          </a:p>
+          <a:p>
+            <a:pPr>
+              <a:spcAft>
+                <a:spcPts val="600"/>
+              </a:spcAft>
+              <a:defRPr sz="1000">
+                <a:solidFill>
+                  <a:srgbClr val="9CA3AF"/>
+                </a:solidFill>
+              </a:defRPr>
+            </a:pPr>
+            <a:r>
+              <a:t>• Civic AI Group — Founder &amp; President: Founded school-wide group with 20+ students and advisors. Developed the core 12-dimension civic health taxonomy, validating the framework with academic rigor. Currently serving 4 diverse departments with 10+ active automation cases.</a:t>
+            </a:r>
+          </a:p>
+          <a:p>
+            <a:pPr>
+              <a:spcAft>
+                <a:spcPts val="600"/>
+              </a:spcAft>
+              <a:defRPr sz="1000">
+                <a:solidFill>
+                  <a:srgbClr val="9CA3AF"/>
+                </a:solidFill>
+              </a:defRPr>
+            </a:pPr>
+            <a:r>
+              <a:t>• AI Simply — Founder: Productivity consulting business weaving best-in-class AI tools with custom code pipelines to automate workflows of SMEs and nonprofits, cutting tedious tasks and reclaiming hundreds of hours. Working with clients from 7 different industries.</a:t>
+            </a:r>
+          </a:p>
+          <a:p>
+            <a:pPr>
+              <a:spcAft>
+                <a:spcPts val="600"/>
+              </a:spcAft>
+              <a:defRPr sz="1000">
+                <a:solidFill>
+                  <a:srgbClr val="9CA3AF"/>
+                </a:solidFill>
+              </a:defRPr>
+            </a:pPr>
+            <a:r>
+              <a:t>• Wisers Information Limited — AI Engineering Intern: Self-developed multi-step program scraping thousands of RedNote (小红书) posts and using LLM analysis to extract latest fashion trends and market strategies of four major sportswear brands.</a:t>
+            </a:r>
+          </a:p>
+          <a:p>
+            <a:pPr>
+              <a:spcAft>
+                <a:spcPts val="600"/>
+              </a:spcAft>
+              <a:defRPr sz="1000">
+                <a:solidFill>
+                  <a:srgbClr val="9CA3AF"/>
+                </a:solidFill>
+              </a:defRPr>
+            </a:pPr>
+          </a:p>
+          <a:p>
+            <a:pPr>
+              <a:spcAft>
+                <a:spcPts val="600"/>
+              </a:spcAft>
+              <a:defRPr sz="1100" b="1">
+                <a:solidFill>
+                  <a:srgbClr val="FFFFFF"/>
+                </a:solidFill>
+              </a:defRPr>
+            </a:pPr>
+            <a:r>
+              <a:t>Technical Expertise: Expert in Agentic AI Workflows (Cursor + Google Antigravity) — capable of executing engineering tasks at 5x the speed of traditional developers, keeping burn rate near zero. Self-developed macOS GUI automation agents combining computer vision (YOLO + OCR) with LLM reasoning.</a:t>
+            </a:r>
+          </a:p>
+          <a:p>
+            <a:pPr>
+              <a:spcAft>
+                <a:spcPts val="600"/>
+              </a:spcAft>
+              <a:defRPr sz="1000">
+                <a:solidFill>
+                  <a:srgbClr val="9CA3AF"/>
+                </a:solidFill>
+              </a:defRPr>
+            </a:pPr>
+          </a:p>
+          <a:p>
+            <a:pPr>
+              <a:spcAft>
+                <a:spcPts val="600"/>
+              </a:spcAft>
+              <a:defRPr sz="1100" b="1">
+                <a:solidFill>
+                  <a:srgbClr val="FFFFFF"/>
+                </a:solidFill>
+              </a:defRPr>
+            </a:pPr>
+            <a:r>
+              <a:t>The Commitment: Dedicated Gap Year (2026-2027) — 100% full-time focus on scaling the venture post-graduation, with commitment to achieving product-market fit and first revenue by Q4 2026.</a:t>
+            </a:r>
+          </a:p>
+          <a:p>
+            <a:pPr>
+              <a:spcAft>
+                <a:spcPts val="600"/>
+              </a:spcAft>
+              <a:defRPr sz="1000">
+                <a:solidFill>
+                  <a:srgbClr val="9CA3AF"/>
+                </a:solidFill>
+              </a:defRPr>
+            </a:pPr>
+          </a:p>
+          <a:p>
+            <a:pPr>
+              <a:spcAft>
+                <a:spcPts val="600"/>
+              </a:spcAft>
+              <a:defRPr sz="1100" b="1">
+                <a:solidFill>
+                  <a:srgbClr val="FFFFFF"/>
+                </a:solidFill>
+              </a:defRPr>
+            </a:pPr>
+            <a:r>
+              <a:t>Additional Leadership: Captain of Varsity Squash Team | Tri-Varsity Athlete | SAILING Leader (Student AI Literacy Group) | Board Member, Advancement Student Board | Drummer &amp; Percussionist, Hon Contemporary Music Band</a:t>
             </a:r>
           </a:p>
         </p:txBody>

</xml_diff>